<commit_message>
CI/CD: deploy job on self-hosted runner (VM); docs updated
</commit_message>
<xml_diff>
--- a/docs/DevOps_CA2_Case_Study.pptx
+++ b/docs/DevOps_CA2_Case_Study.pptx
@@ -3373,7 +3373,7 @@
               <a:defRPr sz="1500"/>
             </a:pPr>
             <a:r>
-              <a:t>• Submitted: deploy.yml + pipeline diagram. Activates with 3 repo secrets (VM_HOST, VM_USER, VM_SSH_KEY)</a:t>
+              <a:t>• Submitted: deploy.yml + pipeline diagram. Deploy job runs on a self-hosted runner on the VM; verified end-to-end: push to build, GHCR, rolling update, health check</a:t>
             </a:r>
           </a:p>
         </p:txBody>
@@ -5204,7 +5204,7 @@
               <a:defRPr sz="1700"/>
             </a:pPr>
             <a:r>
-              <a:t>• Repository: github.com/xzeya/devops-course-work</a:t>
+              <a:t>• Repository: github.com/xzeyo/devops-ca2</a:t>
             </a:r>
           </a:p>
           <a:p>

</xml_diff>

<commit_message>
docs: case study deck — add disk-pressure recovery challenge (real incident)
</commit_message>
<xml_diff>
--- a/docs/DevOps_CA2_Case_Study.pptx
+++ b/docs/DevOps_CA2_Case_Study.pptx
@@ -4028,6 +4028,28 @@
             </a:pPr>
             <a:r>
               <a:t>– → ran ansible-core on the VM with a dedicated SSH key; idempotency proven live (changed=4 → changed=0)</a:t>
+            </a:r>
+          </a:p>
+          <a:p>
+            <a:pPr>
+              <a:spcAft>
+                <a:spcPts val="700"/>
+              </a:spcAft>
+              <a:defRPr sz="1500"/>
+            </a:pPr>
+            <a:r>
+              <a:t>• VM reboot + low disk: kubelet set a disk-pressure taint — node unschedulable, pods evicted, service down for 2 days</a:t>
+            </a:r>
+          </a:p>
+          <a:p>
+            <a:pPr lvl="1">
+              <a:spcAft>
+                <a:spcPts val="700"/>
+              </a:spcAft>
+              <a:defRPr sz="1200"/>
+            </a:pPr>
+            <a:r>
+              <a:t>– → cleaned caches, pruned unused images, purged the host JDK; kubelet lifted the taint and pods rescheduled from the CI-built GHCR image</a:t>
             </a:r>
           </a:p>
         </p:txBody>

</xml_diff>